<commit_message>
Flatten Open-Research-Playbook/ocloud-telemetry-agent/internship into tracked files
</commit_message>
<xml_diff>
--- a/報告/2026-08-06_Richard_Weekly_Status .pptx
+++ b/報告/2026-08-06_Richard_Weekly_Status .pptx
@@ -5884,7 +5884,7 @@
         </p:nvSpPr>
         <p:spPr>
           <a:xfrm>
-            <a:off x="0" y="9801826"/>
+            <a:off x="1600200" y="9258300"/>
             <a:ext cx="9144000" cy="369332"/>
           </a:xfrm>
           <a:prstGeom prst="rect">
@@ -6113,7 +6113,7 @@
               <a:rPr lang="en-US" altLang="zh-TW" sz="4400" dirty="0" err="1">
                 <a:sym typeface="PT Serif"/>
               </a:rPr>
-              <a:t>Tract_A</a:t>
+              <a:t>Track_A</a:t>
             </a:r>
             <a:r>
               <a:rPr lang="en-US" altLang="zh-TW" sz="4400" dirty="0">

</xml_diff>